<commit_message>
Personalize challenge presentation for Raman and Aran Jamal
</commit_message>
<xml_diff>
--- a/docs/presentation/ReachAI-Congressional-App-Challenge.pptx
+++ b/docs/presentation/ReachAI-Congressional-App-Challenge.pptx
@@ -512,7 +512,7 @@
           <a:lstStyle/>
           <a:p>
             <a:r>
-              <a:t>Hi, I am [your name], a [grade] student at [school]. I created ReachAI to make finding food assistance simpler. Replace these placeholders before submitting. This deck shows actual local app screenshots captured October 25, 2026 Central time.</a:t>
+              <a:t>Raman: Hi, I am Raman Jamal, an 11th-grade student at Bryan High. Aran: And I am Aran Jamal, a 7th-grade student at Davila. Together: This is ReachAI, designed to make finding food assistance simpler. This deck shows actual local app screenshots captured October 25, 2026 Central time.</a:t>
             </a:r>
           </a:p>
         </p:txBody>
@@ -582,7 +582,7 @@
           <a:lstStyle/>
           <a:p>
             <a:r>
-              <a:t>ReachAI does not solve food insecurity alone. Its goal is to make a practical next step easier. I am [your name], and this is ReachAI. Thank you. Add a real public demo URL or QR code only after deployment is verified; none has been invented here.</a:t>
+              <a:t>ReachAI does not solve food insecurity alone. Its goal is to make a practical next step easier. We are Raman Jamal and Aran Jamal, and this is ReachAI. Thank you. Add a real public demo URL or QR code only after deployment is verified; none has been invented here.</a:t>
             </a:r>
           </a:p>
         </p:txBody>
@@ -652,7 +652,7 @@
           <a:lstStyle/>
           <a:p>
             <a:r>
-              <a:t>Source appendix; keep available for judges, but it need not be narrated. Source statistics were directly checked on the USDA webpage in this conversation. Screenshot capture: October25,2026 America/Chicago. Software checks are historical reported checks from the latest changes, not user impact measurements. Replace presenter placeholders before submission.</a:t>
+              <a:t>Source appendix; keep available for judges, but it need not be narrated. Source statistics were directly checked on the USDA webpage in this conversation. Screenshot capture: October25,2026 America/Chicago. Software checks are historical reported checks from the latest changes, not user impact measurements. Presenters: Raman Jamal, Bryan High, 11th grade; Aran Jamal, Davila, 7th grade.</a:t>
             </a:r>
           </a:p>
         </p:txBody>
@@ -4610,7 +4610,7 @@
         <p:spPr>
           <a:xfrm>
             <a:off x="533400" y="5334000"/>
-            <a:ext cx="6858000" cy="409575"/>
+            <a:ext cx="7315200" cy="666750"/>
           </a:xfrm>
           <a:prstGeom prst="rect">
             <a:avLst/>
@@ -4635,7 +4635,23 @@
               </a:defRPr>
             </a:pPr>
             <a:r>
-              <a:t>[Your name] · [School / Grade]</a:t>
+              <a:t>Raman Jamal · Bryan High · 11th grade</a:t>
+            </a:r>
+          </a:p>
+          <a:p>
+            <a:pPr>
+              <a:spcAft>
+                <a:spcPts val="450"/>
+              </a:spcAft>
+              <a:defRPr sz="1500" b="0">
+                <a:solidFill>
+                  <a:srgbClr val="ABC1CA"/>
+                </a:solidFill>
+                <a:latin typeface="DejaVu Sans"/>
+              </a:defRPr>
+            </a:pPr>
+            <a:r>
+              <a:t>Aran Jamal · Davila · 7th grade</a:t>
             </a:r>
           </a:p>
         </p:txBody>
@@ -5035,24 +5051,63 @@
         <p:spPr>
           <a:xfrm>
             <a:off x="647700" y="5143500"/>
-            <a:ext cx="10287000" cy="481584"/>
-          </a:xfrm>
-          <a:prstGeom prst="rect">
-            <a:avLst/>
-          </a:prstGeom>
-          <a:noFill/>
-        </p:spPr>
-        <p:txBody>
-          <a:bodyPr wrap="none" lIns="0" rIns="0" tIns="0" bIns="0">
-            <a:spAutoFit/>
-          </a:bodyPr>
-          <a:lstStyle/>
-          <a:p>
-            <a:pPr>
-              <a:spcAft>
-                <a:spcPts val="576"/>
-              </a:spcAft>
-              <a:defRPr sz="1920" b="0">
+            <a:ext cx="10287000" cy="522732"/>
+          </a:xfrm>
+          <a:prstGeom prst="rect">
+            <a:avLst/>
+          </a:prstGeom>
+          <a:noFill/>
+        </p:spPr>
+        <p:txBody>
+          <a:bodyPr wrap="none" lIns="0" rIns="0" tIns="0" bIns="0">
+            <a:spAutoFit/>
+          </a:bodyPr>
+          <a:lstStyle/>
+          <a:p>
+            <a:pPr>
+              <a:spcAft>
+                <a:spcPts val="648"/>
+              </a:spcAft>
+              <a:defRPr sz="2160" b="1">
+                <a:solidFill>
+                  <a:srgbClr val="F1F6F7"/>
+                </a:solidFill>
+                <a:latin typeface="DejaVu Sans"/>
+              </a:defRPr>
+            </a:pPr>
+            <a:r>
+              <a:t>Raman Jamal + Aran Jamal</a:t>
+            </a:r>
+          </a:p>
+        </p:txBody>
+      </p:sp>
+      <p:sp>
+        <p:nvSpPr>
+          <p:cNvPr id="10" name="TextBox 9"/>
+          <p:cNvSpPr txBox="1"/>
+          <p:nvPr/>
+        </p:nvSpPr>
+        <p:spPr>
+          <a:xfrm>
+            <a:off x="647700" y="5676900"/>
+            <a:ext cx="10287000" cy="440436"/>
+          </a:xfrm>
+          <a:prstGeom prst="rect">
+            <a:avLst/>
+          </a:prstGeom>
+          <a:noFill/>
+        </p:spPr>
+        <p:txBody>
+          <a:bodyPr wrap="none" lIns="0" rIns="0" tIns="0" bIns="0">
+            <a:spAutoFit/>
+          </a:bodyPr>
+          <a:lstStyle/>
+          <a:p>
+            <a:pPr>
+              <a:spcAft>
+                <a:spcPts val="504"/>
+              </a:spcAft>
+              <a:defRPr sz="1680" b="0">
                 <a:solidFill>
                   <a:srgbClr val="ABC1CA"/>
                 </a:solidFill>
@@ -5060,7 +5115,7 @@
               </a:defRPr>
             </a:pPr>
             <a:r>
-              <a:t>[Your name] · Thank you</a:t>
+              <a:t>Thank you</a:t>
             </a:r>
           </a:p>
         </p:txBody>

</xml_diff>